<commit_message>
1st Sem : AC Question Update 2025-06-24 07:41:29
</commit_message>
<xml_diff>
--- a/Main/Study/First Sem/All Notes and Resources Combined/AOS Notes/Unit 1.1-Chapter 1 (Process Management ).pptx
+++ b/Main/Study/First Sem/All Notes and Resources Combined/AOS Notes/Unit 1.1-Chapter 1 (Process Management ).pptx
@@ -484,6 +484,45 @@
     </pc:docChg>
   </pc:docChgLst>
   <pc:docChgLst>
+    <pc:chgData name="Yujan Basnet" userId="495fd8277ebfbaef" providerId="LiveId" clId="{6ADDB40C-2293-4884-812F-4CFDF77500C5}"/>
+    <pc:docChg chg="modSld">
+      <pc:chgData name="Yujan Basnet" userId="495fd8277ebfbaef" providerId="LiveId" clId="{6ADDB40C-2293-4884-812F-4CFDF77500C5}" dt="2025-06-19T22:02:37.982" v="1" actId="207"/>
+      <pc:docMkLst>
+        <pc:docMk/>
+      </pc:docMkLst>
+      <pc:sldChg chg="modSp mod">
+        <pc:chgData name="Yujan Basnet" userId="495fd8277ebfbaef" providerId="LiveId" clId="{6ADDB40C-2293-4884-812F-4CFDF77500C5}" dt="2025-06-19T21:12:40.689" v="0" actId="207"/>
+        <pc:sldMkLst>
+          <pc:docMk/>
+          <pc:sldMk cId="0" sldId="258"/>
+        </pc:sldMkLst>
+        <pc:spChg chg="mod">
+          <ac:chgData name="Yujan Basnet" userId="495fd8277ebfbaef" providerId="LiveId" clId="{6ADDB40C-2293-4884-812F-4CFDF77500C5}" dt="2025-06-19T21:12:40.689" v="0" actId="207"/>
+          <ac:spMkLst>
+            <pc:docMk/>
+            <pc:sldMk cId="0" sldId="258"/>
+            <ac:spMk id="3" creationId="{00000000-0000-0000-0000-000000000000}"/>
+          </ac:spMkLst>
+        </pc:spChg>
+      </pc:sldChg>
+      <pc:sldChg chg="modSp mod">
+        <pc:chgData name="Yujan Basnet" userId="495fd8277ebfbaef" providerId="LiveId" clId="{6ADDB40C-2293-4884-812F-4CFDF77500C5}" dt="2025-06-19T22:02:37.982" v="1" actId="207"/>
+        <pc:sldMkLst>
+          <pc:docMk/>
+          <pc:sldMk cId="0" sldId="292"/>
+        </pc:sldMkLst>
+        <pc:spChg chg="mod">
+          <ac:chgData name="Yujan Basnet" userId="495fd8277ebfbaef" providerId="LiveId" clId="{6ADDB40C-2293-4884-812F-4CFDF77500C5}" dt="2025-06-19T22:02:37.982" v="1" actId="207"/>
+          <ac:spMkLst>
+            <pc:docMk/>
+            <pc:sldMk cId="0" sldId="292"/>
+            <ac:spMk id="3" creationId="{00000000-0000-0000-0000-000000000000}"/>
+          </ac:spMkLst>
+        </pc:spChg>
+      </pc:sldChg>
+    </pc:docChg>
+  </pc:docChgLst>
+  <pc:docChgLst>
     <pc:chgData name="Binod Kumar Adhikari" userId="256f5a90-d823-4e8d-9a41-a3da19f4a0ad" providerId="ADAL" clId="{72B1E5E2-E1DF-40A3-807A-F3CEA4DFC89E}"/>
     <pc:docChg chg="undo custSel modSld modMainMaster">
       <pc:chgData name="Binod Kumar Adhikari" userId="256f5a90-d823-4e8d-9a41-a3da19f4a0ad" providerId="ADAL" clId="{72B1E5E2-E1DF-40A3-807A-F3CEA4DFC89E}" dt="2024-03-19T04:27:37.384" v="231" actId="14100"/>
@@ -756,7 +795,7 @@
           <a:p>
             <a:fld id="{5EA01768-F6DF-414D-A051-E1E997691150}" type="datetimeFigureOut">
               <a:rPr lang="en-IN" smtClean="0"/>
-              <a:t>08-04-2025</a:t>
+              <a:t>20-06-2025</a:t>
             </a:fld>
             <a:endParaRPr lang="en-IN"/>
           </a:p>
@@ -22147,6 +22186,9 @@
             </a:pPr>
             <a:r>
               <a:rPr sz="3200" dirty="0">
+                <a:solidFill>
+                  <a:srgbClr val="00B050"/>
+                </a:solidFill>
                 <a:latin typeface="Calibri"/>
                 <a:cs typeface="Calibri"/>
               </a:rPr>
@@ -22154,6 +22196,9 @@
             </a:r>
             <a:r>
               <a:rPr sz="3200" spc="-105" dirty="0">
+                <a:solidFill>
+                  <a:srgbClr val="00B050"/>
+                </a:solidFill>
                 <a:latin typeface="Calibri"/>
                 <a:cs typeface="Calibri"/>
               </a:rPr>
@@ -22161,6 +22206,9 @@
             </a:r>
             <a:r>
               <a:rPr sz="3200" dirty="0">
+                <a:solidFill>
+                  <a:srgbClr val="00B050"/>
+                </a:solidFill>
                 <a:latin typeface="Calibri"/>
                 <a:cs typeface="Calibri"/>
               </a:rPr>
@@ -22168,6 +22216,9 @@
             </a:r>
             <a:r>
               <a:rPr sz="3200" spc="-60" dirty="0">
+                <a:solidFill>
+                  <a:srgbClr val="00B050"/>
+                </a:solidFill>
                 <a:latin typeface="Calibri"/>
                 <a:cs typeface="Calibri"/>
               </a:rPr>
@@ -22175,6 +22226,9 @@
             </a:r>
             <a:r>
               <a:rPr sz="3200" dirty="0">
+                <a:solidFill>
+                  <a:srgbClr val="00B050"/>
+                </a:solidFill>
                 <a:latin typeface="Calibri"/>
                 <a:cs typeface="Calibri"/>
               </a:rPr>
@@ -22182,6 +22236,9 @@
             </a:r>
             <a:r>
               <a:rPr sz="3200" spc="-60" dirty="0">
+                <a:solidFill>
+                  <a:srgbClr val="00B050"/>
+                </a:solidFill>
                 <a:latin typeface="Calibri"/>
                 <a:cs typeface="Calibri"/>
               </a:rPr>
@@ -22189,6 +22246,9 @@
             </a:r>
             <a:r>
               <a:rPr sz="3200" dirty="0">
+                <a:solidFill>
+                  <a:srgbClr val="00B050"/>
+                </a:solidFill>
                 <a:latin typeface="Calibri"/>
                 <a:cs typeface="Calibri"/>
               </a:rPr>
@@ -22196,6 +22256,9 @@
             </a:r>
             <a:r>
               <a:rPr sz="3200" spc="-65" dirty="0">
+                <a:solidFill>
+                  <a:srgbClr val="00B050"/>
+                </a:solidFill>
                 <a:latin typeface="Calibri"/>
                 <a:cs typeface="Calibri"/>
               </a:rPr>
@@ -22203,6 +22266,9 @@
             </a:r>
             <a:r>
               <a:rPr sz="3200" dirty="0">
+                <a:solidFill>
+                  <a:srgbClr val="00B050"/>
+                </a:solidFill>
                 <a:latin typeface="Calibri"/>
                 <a:cs typeface="Calibri"/>
               </a:rPr>
@@ -22210,6 +22276,9 @@
             </a:r>
             <a:r>
               <a:rPr sz="3200" spc="-55" dirty="0">
+                <a:solidFill>
+                  <a:srgbClr val="00B050"/>
+                </a:solidFill>
                 <a:latin typeface="Calibri"/>
                 <a:cs typeface="Calibri"/>
               </a:rPr>
@@ -22217,12 +22286,18 @@
             </a:r>
             <a:r>
               <a:rPr sz="3200" spc="-10" dirty="0">
+                <a:solidFill>
+                  <a:srgbClr val="00B050"/>
+                </a:solidFill>
                 <a:latin typeface="Calibri"/>
                 <a:cs typeface="Calibri"/>
               </a:rPr>
               <a:t>execution</a:t>
             </a:r>
             <a:endParaRPr sz="3200" dirty="0">
+              <a:solidFill>
+                <a:srgbClr val="00B050"/>
+              </a:solidFill>
               <a:latin typeface="Calibri"/>
               <a:cs typeface="Calibri"/>
             </a:endParaRPr>
@@ -29521,6 +29596,9 @@
             </a:r>
             <a:r>
               <a:rPr sz="2800" dirty="0">
+                <a:solidFill>
+                  <a:srgbClr val="00B050"/>
+                </a:solidFill>
                 <a:latin typeface="Times New Roman"/>
                 <a:cs typeface="Times New Roman"/>
               </a:rPr>
@@ -29528,6 +29606,9 @@
             </a:r>
             <a:r>
               <a:rPr sz="2800" spc="-45" dirty="0">
+                <a:solidFill>
+                  <a:srgbClr val="00B050"/>
+                </a:solidFill>
                 <a:latin typeface="Times New Roman"/>
                 <a:cs typeface="Times New Roman"/>
               </a:rPr>
@@ -29535,10 +29616,20 @@
             </a:r>
             <a:r>
               <a:rPr sz="2800" spc="-10" dirty="0">
-                <a:latin typeface="Times New Roman"/>
-                <a:cs typeface="Times New Roman"/>
-              </a:rPr>
-              <a:t>directory;</a:t>
+                <a:solidFill>
+                  <a:srgbClr val="00B050"/>
+                </a:solidFill>
+                <a:latin typeface="Times New Roman"/>
+                <a:cs typeface="Times New Roman"/>
+              </a:rPr>
+              <a:t>directory</a:t>
+            </a:r>
+            <a:r>
+              <a:rPr sz="2800" spc="-10" dirty="0">
+                <a:latin typeface="Times New Roman"/>
+                <a:cs typeface="Times New Roman"/>
+              </a:rPr>
+              <a:t>;</a:t>
             </a:r>
             <a:endParaRPr sz="2800" dirty="0">
               <a:latin typeface="Times New Roman"/>

</xml_diff>